<commit_message>
Deploy Classic Youth Knowledge Base Portal and EP605 Zero-Noise Briefing
</commit_message>
<xml_diff>
--- a/episodes/ep605/經典也青春EP605_陳國偉談楊双子的《臺灣漫遊錄》_無雜訊顧問簡報.pptx
+++ b/episodes/ep605/經典也青春EP605_陳國偉談楊双子的《臺灣漫遊錄》_無雜訊顧問簡報.pptx
@@ -5224,40 +5224,16 @@
           </a:p>
         </p:txBody>
       </p:sp>
-      <p:pic>
-        <p:nvPicPr>
-          <p:cNvPr id="17" name="Picture 16" descr="timeless_book.jpg"/>
-          <p:cNvPicPr>
-            <a:picLocks noChangeAspect="1"/>
-          </p:cNvPicPr>
-          <p:nvPr/>
-        </p:nvPicPr>
-        <p:blipFill>
-          <a:blip r:embed="rId2"/>
-          <a:stretch>
-            <a:fillRect/>
-          </a:stretch>
-        </p:blipFill>
+      <p:sp>
+        <p:nvSpPr>
+          <p:cNvPr id="17" name="TextBox 16"/>
+          <p:cNvSpPr txBox="1"/>
+          <p:nvPr/>
+        </p:nvSpPr>
         <p:spPr>
           <a:xfrm>
             <a:off x="7178040" y="2011680"/>
-            <a:ext cx="4023360" cy="1828800"/>
-          </a:xfrm>
-          <a:prstGeom prst="rect">
-            <a:avLst/>
-          </a:prstGeom>
-        </p:spPr>
-      </p:pic>
-      <p:sp>
-        <p:nvSpPr>
-          <p:cNvPr id="18" name="TextBox 17"/>
-          <p:cNvSpPr txBox="1"/>
-          <p:nvPr/>
-        </p:nvSpPr>
-        <p:spPr>
-          <a:xfrm>
-            <a:off x="7178040" y="3977639"/>
-            <a:ext cx="4023360" cy="2011680"/>
+            <a:ext cx="4023360" cy="3931920"/>
           </a:xfrm>
           <a:prstGeom prst="rect">
             <a:avLst/>
@@ -5943,40 +5919,16 @@
           </a:p>
         </p:txBody>
       </p:sp>
-      <p:pic>
-        <p:nvPicPr>
-          <p:cNvPr id="17" name="Picture 16" descr="awards_recognition.jpg"/>
-          <p:cNvPicPr>
-            <a:picLocks noChangeAspect="1"/>
-          </p:cNvPicPr>
-          <p:nvPr/>
-        </p:nvPicPr>
-        <p:blipFill>
-          <a:blip r:embed="rId2"/>
-          <a:stretch>
-            <a:fillRect/>
-          </a:stretch>
-        </p:blipFill>
+      <p:sp>
+        <p:nvSpPr>
+          <p:cNvPr id="17" name="TextBox 16"/>
+          <p:cNvSpPr txBox="1"/>
+          <p:nvPr/>
+        </p:nvSpPr>
         <p:spPr>
           <a:xfrm>
             <a:off x="7178040" y="2011680"/>
-            <a:ext cx="4023360" cy="1828800"/>
-          </a:xfrm>
-          <a:prstGeom prst="rect">
-            <a:avLst/>
-          </a:prstGeom>
-        </p:spPr>
-      </p:pic>
-      <p:sp>
-        <p:nvSpPr>
-          <p:cNvPr id="18" name="TextBox 17"/>
-          <p:cNvSpPr txBox="1"/>
-          <p:nvPr/>
-        </p:nvSpPr>
-        <p:spPr>
-          <a:xfrm>
-            <a:off x="7178040" y="3977639"/>
-            <a:ext cx="4023360" cy="2011680"/>
+            <a:ext cx="4023360" cy="3931920"/>
           </a:xfrm>
           <a:prstGeom prst="rect">
             <a:avLst/>
@@ -6278,40 +6230,16 @@
           </a:p>
         </p:txBody>
       </p:sp>
-      <p:pic>
-        <p:nvPicPr>
-          <p:cNvPr id="7" name="Picture 6" descr="taiwan_travelogue_cover.jpg"/>
-          <p:cNvPicPr>
-            <a:picLocks noChangeAspect="1"/>
-          </p:cNvPicPr>
-          <p:nvPr/>
-        </p:nvPicPr>
-        <p:blipFill>
-          <a:blip r:embed="rId2"/>
-          <a:stretch>
-            <a:fillRect/>
-          </a:stretch>
-        </p:blipFill>
-        <p:spPr>
-          <a:xfrm>
-            <a:off x="8595360" y="1828800"/>
-            <a:ext cx="2834640" cy="4389120"/>
-          </a:xfrm>
-          <a:prstGeom prst="rect">
-            <a:avLst/>
-          </a:prstGeom>
-        </p:spPr>
-      </p:pic>
-      <p:sp>
-        <p:nvSpPr>
-          <p:cNvPr id="8" name="Rounded Rectangle 7"/>
+      <p:sp>
+        <p:nvSpPr>
+          <p:cNvPr id="7" name="Rounded Rectangle 6"/>
           <p:cNvSpPr/>
           <p:nvPr/>
         </p:nvSpPr>
         <p:spPr>
           <a:xfrm>
             <a:off x="731520" y="1828800"/>
-            <a:ext cx="2438400" cy="4389120"/>
+            <a:ext cx="3423818" cy="4389120"/>
           </a:xfrm>
           <a:prstGeom prst="roundRect">
             <a:avLst/>
@@ -6349,14 +6277,14 @@
       </p:sp>
       <p:sp>
         <p:nvSpPr>
-          <p:cNvPr id="9" name="Rectangle 8"/>
+          <p:cNvPr id="8" name="Rectangle 7"/>
           <p:cNvSpPr/>
           <p:nvPr/>
         </p:nvSpPr>
         <p:spPr>
           <a:xfrm>
             <a:off x="731520" y="1828800"/>
-            <a:ext cx="2438400" cy="457200"/>
+            <a:ext cx="3423818" cy="457200"/>
           </a:xfrm>
           <a:prstGeom prst="rect">
             <a:avLst/>
@@ -6401,14 +6329,14 @@
       </p:sp>
       <p:sp>
         <p:nvSpPr>
-          <p:cNvPr id="10" name="TextBox 9"/>
+          <p:cNvPr id="9" name="TextBox 8"/>
           <p:cNvSpPr txBox="1"/>
           <p:nvPr/>
         </p:nvSpPr>
         <p:spPr>
           <a:xfrm>
             <a:off x="868680" y="2423160"/>
-            <a:ext cx="2164080" cy="3657600"/>
+            <a:ext cx="3149498" cy="3657600"/>
           </a:xfrm>
           <a:prstGeom prst="rect">
             <a:avLst/>
@@ -6469,14 +6397,14 @@
       </p:sp>
       <p:sp>
         <p:nvSpPr>
-          <p:cNvPr id="11" name="Rounded Rectangle 10"/>
+          <p:cNvPr id="10" name="Rounded Rectangle 9"/>
           <p:cNvSpPr/>
           <p:nvPr/>
         </p:nvSpPr>
         <p:spPr>
           <a:xfrm>
-            <a:off x="3352800" y="1828800"/>
-            <a:ext cx="2438400" cy="4389120"/>
+            <a:off x="4383938" y="1828800"/>
+            <a:ext cx="3423818" cy="4389120"/>
           </a:xfrm>
           <a:prstGeom prst="roundRect">
             <a:avLst/>
@@ -6514,14 +6442,14 @@
       </p:sp>
       <p:sp>
         <p:nvSpPr>
-          <p:cNvPr id="12" name="Rectangle 11"/>
+          <p:cNvPr id="11" name="Rectangle 10"/>
           <p:cNvSpPr/>
           <p:nvPr/>
         </p:nvSpPr>
         <p:spPr>
           <a:xfrm>
-            <a:off x="3352800" y="1828800"/>
-            <a:ext cx="2438400" cy="457200"/>
+            <a:off x="4383938" y="1828800"/>
+            <a:ext cx="3423818" cy="457200"/>
           </a:xfrm>
           <a:prstGeom prst="rect">
             <a:avLst/>
@@ -6566,14 +6494,14 @@
       </p:sp>
       <p:sp>
         <p:nvSpPr>
-          <p:cNvPr id="13" name="TextBox 12"/>
+          <p:cNvPr id="12" name="TextBox 11"/>
           <p:cNvSpPr txBox="1"/>
           <p:nvPr/>
         </p:nvSpPr>
         <p:spPr>
           <a:xfrm>
-            <a:off x="3489960" y="2423160"/>
-            <a:ext cx="2164080" cy="3657600"/>
+            <a:off x="4521098" y="2423160"/>
+            <a:ext cx="3149498" cy="3657600"/>
           </a:xfrm>
           <a:prstGeom prst="rect">
             <a:avLst/>
@@ -6634,14 +6562,14 @@
       </p:sp>
       <p:sp>
         <p:nvSpPr>
-          <p:cNvPr id="14" name="Rounded Rectangle 13"/>
+          <p:cNvPr id="13" name="Rounded Rectangle 12"/>
           <p:cNvSpPr/>
           <p:nvPr/>
         </p:nvSpPr>
         <p:spPr>
           <a:xfrm>
-            <a:off x="5974080" y="1828800"/>
-            <a:ext cx="2438400" cy="4389120"/>
+            <a:off x="8036356" y="1828800"/>
+            <a:ext cx="3423818" cy="4389120"/>
           </a:xfrm>
           <a:prstGeom prst="roundRect">
             <a:avLst/>
@@ -6679,14 +6607,14 @@
       </p:sp>
       <p:sp>
         <p:nvSpPr>
-          <p:cNvPr id="15" name="Rectangle 14"/>
+          <p:cNvPr id="14" name="Rectangle 13"/>
           <p:cNvSpPr/>
           <p:nvPr/>
         </p:nvSpPr>
         <p:spPr>
           <a:xfrm>
-            <a:off x="5974080" y="1828800"/>
-            <a:ext cx="2438400" cy="457200"/>
+            <a:off x="8036356" y="1828800"/>
+            <a:ext cx="3423818" cy="457200"/>
           </a:xfrm>
           <a:prstGeom prst="rect">
             <a:avLst/>
@@ -6731,14 +6659,14 @@
       </p:sp>
       <p:sp>
         <p:nvSpPr>
-          <p:cNvPr id="16" name="TextBox 15"/>
+          <p:cNvPr id="15" name="TextBox 14"/>
           <p:cNvSpPr txBox="1"/>
           <p:nvPr/>
         </p:nvSpPr>
         <p:spPr>
           <a:xfrm>
-            <a:off x="6111240" y="2423160"/>
-            <a:ext cx="2164080" cy="3657600"/>
+            <a:off x="8173516" y="2423160"/>
+            <a:ext cx="3149498" cy="3657600"/>
           </a:xfrm>
           <a:prstGeom prst="rect">
             <a:avLst/>
@@ -7019,7 +6947,7 @@
         <p:spPr>
           <a:xfrm>
             <a:off x="731520" y="1783080"/>
-            <a:ext cx="7498079" cy="347472"/>
+            <a:ext cx="10728655" cy="347472"/>
           </a:xfrm>
           <a:prstGeom prst="rightArrow">
             <a:avLst/>
@@ -7062,40 +6990,16 @@
           </a:p>
         </p:txBody>
       </p:sp>
-      <p:pic>
-        <p:nvPicPr>
-          <p:cNvPr id="8" name="Picture 7" descr="railway_station.jpg"/>
-          <p:cNvPicPr>
-            <a:picLocks noChangeAspect="1"/>
-          </p:cNvPicPr>
-          <p:nvPr/>
-        </p:nvPicPr>
-        <p:blipFill>
-          <a:blip r:embed="rId2"/>
-          <a:stretch>
-            <a:fillRect/>
-          </a:stretch>
-        </p:blipFill>
-        <p:spPr>
-          <a:xfrm>
-            <a:off x="8503920" y="1783080"/>
-            <a:ext cx="2926080" cy="4389120"/>
-          </a:xfrm>
-          <a:prstGeom prst="rect">
-            <a:avLst/>
-          </a:prstGeom>
-        </p:spPr>
-      </p:pic>
-      <p:sp>
-        <p:nvSpPr>
-          <p:cNvPr id="9" name="Chevron 8"/>
+      <p:sp>
+        <p:nvSpPr>
+          <p:cNvPr id="8" name="Chevron 7"/>
           <p:cNvSpPr/>
           <p:nvPr/>
         </p:nvSpPr>
         <p:spPr>
           <a:xfrm>
             <a:off x="731520" y="2286000"/>
-            <a:ext cx="2377439" cy="685800"/>
+            <a:ext cx="3423818" cy="685800"/>
           </a:xfrm>
           <a:prstGeom prst="chevron">
             <a:avLst/>
@@ -7140,14 +7044,14 @@
       </p:sp>
       <p:sp>
         <p:nvSpPr>
-          <p:cNvPr id="10" name="Rounded Rectangle 9"/>
+          <p:cNvPr id="9" name="Rounded Rectangle 8"/>
           <p:cNvSpPr/>
           <p:nvPr/>
         </p:nvSpPr>
         <p:spPr>
           <a:xfrm>
             <a:off x="731520" y="3108960"/>
-            <a:ext cx="2377439" cy="3017520"/>
+            <a:ext cx="3423818" cy="3017520"/>
           </a:xfrm>
           <a:prstGeom prst="roundRect">
             <a:avLst/>
@@ -7185,14 +7089,14 @@
       </p:sp>
       <p:sp>
         <p:nvSpPr>
-          <p:cNvPr id="11" name="TextBox 10"/>
+          <p:cNvPr id="10" name="TextBox 9"/>
           <p:cNvSpPr txBox="1"/>
           <p:nvPr/>
         </p:nvSpPr>
         <p:spPr>
           <a:xfrm>
             <a:off x="868680" y="3246120"/>
-            <a:ext cx="2103120" cy="2743200"/>
+            <a:ext cx="3149498" cy="2743200"/>
           </a:xfrm>
           <a:prstGeom prst="rect">
             <a:avLst/>
@@ -7253,14 +7157,14 @@
       </p:sp>
       <p:sp>
         <p:nvSpPr>
-          <p:cNvPr id="12" name="Chevron 11"/>
+          <p:cNvPr id="11" name="Chevron 10"/>
           <p:cNvSpPr/>
           <p:nvPr/>
         </p:nvSpPr>
         <p:spPr>
           <a:xfrm>
-            <a:off x="3291839" y="2286000"/>
-            <a:ext cx="2377439" cy="685800"/>
+            <a:off x="4383938" y="2286000"/>
+            <a:ext cx="3423818" cy="685800"/>
           </a:xfrm>
           <a:prstGeom prst="chevron">
             <a:avLst/>
@@ -7305,14 +7209,14 @@
       </p:sp>
       <p:sp>
         <p:nvSpPr>
-          <p:cNvPr id="13" name="Rounded Rectangle 12"/>
+          <p:cNvPr id="12" name="Rounded Rectangle 11"/>
           <p:cNvSpPr/>
           <p:nvPr/>
         </p:nvSpPr>
         <p:spPr>
           <a:xfrm>
-            <a:off x="3291839" y="3108960"/>
-            <a:ext cx="2377439" cy="3017520"/>
+            <a:off x="4383938" y="3108960"/>
+            <a:ext cx="3423818" cy="3017520"/>
           </a:xfrm>
           <a:prstGeom prst="roundRect">
             <a:avLst/>
@@ -7350,14 +7254,14 @@
       </p:sp>
       <p:sp>
         <p:nvSpPr>
-          <p:cNvPr id="14" name="TextBox 13"/>
+          <p:cNvPr id="13" name="TextBox 12"/>
           <p:cNvSpPr txBox="1"/>
           <p:nvPr/>
         </p:nvSpPr>
         <p:spPr>
           <a:xfrm>
-            <a:off x="3428999" y="3246120"/>
-            <a:ext cx="2103120" cy="2743200"/>
+            <a:off x="4521098" y="3246120"/>
+            <a:ext cx="3149498" cy="2743200"/>
           </a:xfrm>
           <a:prstGeom prst="rect">
             <a:avLst/>
@@ -7418,14 +7322,14 @@
       </p:sp>
       <p:sp>
         <p:nvSpPr>
-          <p:cNvPr id="15" name="Chevron 14"/>
+          <p:cNvPr id="14" name="Chevron 13"/>
           <p:cNvSpPr/>
           <p:nvPr/>
         </p:nvSpPr>
         <p:spPr>
           <a:xfrm>
-            <a:off x="5852159" y="2286000"/>
-            <a:ext cx="2377439" cy="685800"/>
+            <a:off x="8036356" y="2286000"/>
+            <a:ext cx="3423818" cy="685800"/>
           </a:xfrm>
           <a:prstGeom prst="chevron">
             <a:avLst/>
@@ -7470,14 +7374,14 @@
       </p:sp>
       <p:sp>
         <p:nvSpPr>
-          <p:cNvPr id="16" name="Rounded Rectangle 15"/>
+          <p:cNvPr id="15" name="Rounded Rectangle 14"/>
           <p:cNvSpPr/>
           <p:nvPr/>
         </p:nvSpPr>
         <p:spPr>
           <a:xfrm>
-            <a:off x="5852159" y="3108960"/>
-            <a:ext cx="2377439" cy="3017520"/>
+            <a:off x="8036356" y="3108960"/>
+            <a:ext cx="3423818" cy="3017520"/>
           </a:xfrm>
           <a:prstGeom prst="roundRect">
             <a:avLst/>
@@ -7515,14 +7419,14 @@
       </p:sp>
       <p:sp>
         <p:nvSpPr>
-          <p:cNvPr id="17" name="TextBox 16"/>
+          <p:cNvPr id="16" name="TextBox 15"/>
           <p:cNvSpPr txBox="1"/>
           <p:nvPr/>
         </p:nvSpPr>
         <p:spPr>
           <a:xfrm>
-            <a:off x="5989320" y="3246120"/>
-            <a:ext cx="2103120" cy="2743200"/>
+            <a:off x="8173516" y="3246120"/>
+            <a:ext cx="3149498" cy="2743200"/>
           </a:xfrm>
           <a:prstGeom prst="rect">
             <a:avLst/>
@@ -7794,40 +7698,16 @@
           </a:p>
         </p:txBody>
       </p:sp>
-      <p:pic>
-        <p:nvPicPr>
-          <p:cNvPr id="7" name="Picture 6" descr="two_women_dialogue.jpg"/>
-          <p:cNvPicPr>
-            <a:picLocks noChangeAspect="1"/>
-          </p:cNvPicPr>
-          <p:nvPr/>
-        </p:nvPicPr>
-        <p:blipFill>
-          <a:blip r:embed="rId2"/>
-          <a:stretch>
-            <a:fillRect/>
-          </a:stretch>
-        </p:blipFill>
-        <p:spPr>
-          <a:xfrm>
-            <a:off x="8778240" y="1783080"/>
-            <a:ext cx="2651760" cy="4389120"/>
-          </a:xfrm>
-          <a:prstGeom prst="rect">
-            <a:avLst/>
-          </a:prstGeom>
-        </p:spPr>
-      </p:pic>
-      <p:sp>
-        <p:nvSpPr>
-          <p:cNvPr id="8" name="Chevron 7"/>
+      <p:sp>
+        <p:nvSpPr>
+          <p:cNvPr id="7" name="Chevron 6"/>
           <p:cNvSpPr/>
           <p:nvPr/>
         </p:nvSpPr>
         <p:spPr>
           <a:xfrm>
-            <a:off x="2606040" y="1783080"/>
-            <a:ext cx="1371600" cy="548640"/>
+            <a:off x="2880360" y="1783080"/>
+            <a:ext cx="2042083" cy="548640"/>
           </a:xfrm>
           <a:prstGeom prst="chevron">
             <a:avLst/>
@@ -7872,14 +7752,14 @@
       </p:sp>
       <p:sp>
         <p:nvSpPr>
-          <p:cNvPr id="9" name="Chevron 8"/>
+          <p:cNvPr id="8" name="Chevron 7"/>
           <p:cNvSpPr/>
           <p:nvPr/>
         </p:nvSpPr>
         <p:spPr>
           <a:xfrm>
-            <a:off x="4114800" y="1783080"/>
-            <a:ext cx="1371600" cy="548640"/>
+            <a:off x="5059603" y="1783080"/>
+            <a:ext cx="2042083" cy="548640"/>
           </a:xfrm>
           <a:prstGeom prst="chevron">
             <a:avLst/>
@@ -7924,14 +7804,14 @@
       </p:sp>
       <p:sp>
         <p:nvSpPr>
-          <p:cNvPr id="10" name="Chevron 9"/>
+          <p:cNvPr id="9" name="Chevron 8"/>
           <p:cNvSpPr/>
           <p:nvPr/>
         </p:nvSpPr>
         <p:spPr>
           <a:xfrm>
-            <a:off x="5623560" y="1783080"/>
-            <a:ext cx="1371600" cy="548640"/>
+            <a:off x="7238847" y="1783080"/>
+            <a:ext cx="2042083" cy="548640"/>
           </a:xfrm>
           <a:prstGeom prst="chevron">
             <a:avLst/>
@@ -7976,14 +7856,14 @@
       </p:sp>
       <p:sp>
         <p:nvSpPr>
-          <p:cNvPr id="11" name="Chevron 10"/>
+          <p:cNvPr id="10" name="Chevron 9"/>
           <p:cNvSpPr/>
           <p:nvPr/>
         </p:nvSpPr>
         <p:spPr>
           <a:xfrm>
-            <a:off x="7132319" y="1783080"/>
-            <a:ext cx="1371600" cy="548640"/>
+            <a:off x="9418091" y="1783080"/>
+            <a:ext cx="2042083" cy="548640"/>
           </a:xfrm>
           <a:prstGeom prst="chevron">
             <a:avLst/>
@@ -8028,14 +7908,14 @@
       </p:sp>
       <p:sp>
         <p:nvSpPr>
-          <p:cNvPr id="12" name="Rectangle 11"/>
+          <p:cNvPr id="11" name="Rectangle 10"/>
           <p:cNvSpPr/>
           <p:nvPr/>
         </p:nvSpPr>
         <p:spPr>
           <a:xfrm>
             <a:off x="731520" y="2514600"/>
-            <a:ext cx="1737360" cy="1737360"/>
+            <a:ext cx="2011680" cy="1737360"/>
           </a:xfrm>
           <a:prstGeom prst="rect">
             <a:avLst/>
@@ -8080,14 +7960,14 @@
       </p:sp>
       <p:sp>
         <p:nvSpPr>
-          <p:cNvPr id="13" name="Rounded Rectangle 12"/>
+          <p:cNvPr id="12" name="Rounded Rectangle 11"/>
           <p:cNvSpPr/>
           <p:nvPr/>
         </p:nvSpPr>
         <p:spPr>
           <a:xfrm>
-            <a:off x="2606040" y="2514600"/>
-            <a:ext cx="1371600" cy="1737360"/>
+            <a:off x="2880360" y="2514600"/>
+            <a:ext cx="2042083" cy="1737360"/>
           </a:xfrm>
           <a:prstGeom prst="roundRect">
             <a:avLst/>
@@ -8125,14 +8005,14 @@
       </p:sp>
       <p:sp>
         <p:nvSpPr>
-          <p:cNvPr id="14" name="TextBox 13"/>
+          <p:cNvPr id="13" name="TextBox 12"/>
           <p:cNvSpPr txBox="1"/>
           <p:nvPr/>
         </p:nvSpPr>
         <p:spPr>
           <a:xfrm>
-            <a:off x="2697480" y="2606040"/>
-            <a:ext cx="1188720" cy="1554480"/>
+            <a:off x="2971800" y="2606040"/>
+            <a:ext cx="1859203" cy="1554480"/>
           </a:xfrm>
           <a:prstGeom prst="rect">
             <a:avLst/>
@@ -8160,14 +8040,14 @@
       </p:sp>
       <p:sp>
         <p:nvSpPr>
-          <p:cNvPr id="15" name="Rounded Rectangle 14"/>
+          <p:cNvPr id="14" name="Rounded Rectangle 13"/>
           <p:cNvSpPr/>
           <p:nvPr/>
         </p:nvSpPr>
         <p:spPr>
           <a:xfrm>
-            <a:off x="4114800" y="2514600"/>
-            <a:ext cx="1371600" cy="1737360"/>
+            <a:off x="5059603" y="2514600"/>
+            <a:ext cx="2042083" cy="1737360"/>
           </a:xfrm>
           <a:prstGeom prst="roundRect">
             <a:avLst/>
@@ -8205,14 +8085,14 @@
       </p:sp>
       <p:sp>
         <p:nvSpPr>
-          <p:cNvPr id="16" name="TextBox 15"/>
+          <p:cNvPr id="15" name="TextBox 14"/>
           <p:cNvSpPr txBox="1"/>
           <p:nvPr/>
         </p:nvSpPr>
         <p:spPr>
           <a:xfrm>
-            <a:off x="4206240" y="2606040"/>
-            <a:ext cx="1188720" cy="1554480"/>
+            <a:off x="5151043" y="2606040"/>
+            <a:ext cx="1859203" cy="1554480"/>
           </a:xfrm>
           <a:prstGeom prst="rect">
             <a:avLst/>
@@ -8240,14 +8120,14 @@
       </p:sp>
       <p:sp>
         <p:nvSpPr>
-          <p:cNvPr id="17" name="Rounded Rectangle 16"/>
+          <p:cNvPr id="16" name="Rounded Rectangle 15"/>
           <p:cNvSpPr/>
           <p:nvPr/>
         </p:nvSpPr>
         <p:spPr>
           <a:xfrm>
-            <a:off x="5623560" y="2514600"/>
-            <a:ext cx="1371600" cy="1737360"/>
+            <a:off x="7238847" y="2514600"/>
+            <a:ext cx="2042083" cy="1737360"/>
           </a:xfrm>
           <a:prstGeom prst="roundRect">
             <a:avLst/>
@@ -8285,14 +8165,14 @@
       </p:sp>
       <p:sp>
         <p:nvSpPr>
-          <p:cNvPr id="18" name="TextBox 17"/>
+          <p:cNvPr id="17" name="TextBox 16"/>
           <p:cNvSpPr txBox="1"/>
           <p:nvPr/>
         </p:nvSpPr>
         <p:spPr>
           <a:xfrm>
-            <a:off x="5715000" y="2606040"/>
-            <a:ext cx="1188720" cy="1554480"/>
+            <a:off x="7330287" y="2606040"/>
+            <a:ext cx="1859203" cy="1554480"/>
           </a:xfrm>
           <a:prstGeom prst="rect">
             <a:avLst/>
@@ -8320,14 +8200,14 @@
       </p:sp>
       <p:sp>
         <p:nvSpPr>
-          <p:cNvPr id="19" name="Rounded Rectangle 18"/>
+          <p:cNvPr id="18" name="Rounded Rectangle 17"/>
           <p:cNvSpPr/>
           <p:nvPr/>
         </p:nvSpPr>
         <p:spPr>
           <a:xfrm>
-            <a:off x="7132319" y="2514600"/>
-            <a:ext cx="1371600" cy="1737360"/>
+            <a:off x="9418091" y="2514600"/>
+            <a:ext cx="2042083" cy="1737360"/>
           </a:xfrm>
           <a:prstGeom prst="roundRect">
             <a:avLst/>
@@ -8365,14 +8245,14 @@
       </p:sp>
       <p:sp>
         <p:nvSpPr>
-          <p:cNvPr id="20" name="TextBox 19"/>
+          <p:cNvPr id="19" name="TextBox 18"/>
           <p:cNvSpPr txBox="1"/>
           <p:nvPr/>
         </p:nvSpPr>
         <p:spPr>
           <a:xfrm>
-            <a:off x="7223759" y="2606040"/>
-            <a:ext cx="1188720" cy="1554480"/>
+            <a:off x="9509531" y="2606040"/>
+            <a:ext cx="1859203" cy="1554480"/>
           </a:xfrm>
           <a:prstGeom prst="rect">
             <a:avLst/>
@@ -8400,14 +8280,14 @@
       </p:sp>
       <p:sp>
         <p:nvSpPr>
-          <p:cNvPr id="21" name="Rectangle 20"/>
+          <p:cNvPr id="20" name="Rectangle 19"/>
           <p:cNvSpPr/>
           <p:nvPr/>
         </p:nvSpPr>
         <p:spPr>
           <a:xfrm>
             <a:off x="731520" y="4389120"/>
-            <a:ext cx="1737360" cy="1737360"/>
+            <a:ext cx="2011680" cy="1737360"/>
           </a:xfrm>
           <a:prstGeom prst="rect">
             <a:avLst/>
@@ -8452,14 +8332,14 @@
       </p:sp>
       <p:sp>
         <p:nvSpPr>
-          <p:cNvPr id="22" name="Rounded Rectangle 21"/>
+          <p:cNvPr id="21" name="Rounded Rectangle 20"/>
           <p:cNvSpPr/>
           <p:nvPr/>
         </p:nvSpPr>
         <p:spPr>
           <a:xfrm>
-            <a:off x="2606040" y="4389120"/>
-            <a:ext cx="1371600" cy="1737360"/>
+            <a:off x="2880360" y="4389120"/>
+            <a:ext cx="2042083" cy="1737360"/>
           </a:xfrm>
           <a:prstGeom prst="roundRect">
             <a:avLst/>
@@ -8497,14 +8377,14 @@
       </p:sp>
       <p:sp>
         <p:nvSpPr>
-          <p:cNvPr id="23" name="TextBox 22"/>
+          <p:cNvPr id="22" name="TextBox 21"/>
           <p:cNvSpPr txBox="1"/>
           <p:nvPr/>
         </p:nvSpPr>
         <p:spPr>
           <a:xfrm>
-            <a:off x="2697480" y="4480559"/>
-            <a:ext cx="1188720" cy="1554480"/>
+            <a:off x="2971800" y="4480559"/>
+            <a:ext cx="1859203" cy="1554480"/>
           </a:xfrm>
           <a:prstGeom prst="rect">
             <a:avLst/>
@@ -8532,14 +8412,14 @@
       </p:sp>
       <p:sp>
         <p:nvSpPr>
-          <p:cNvPr id="24" name="Rounded Rectangle 23"/>
+          <p:cNvPr id="23" name="Rounded Rectangle 22"/>
           <p:cNvSpPr/>
           <p:nvPr/>
         </p:nvSpPr>
         <p:spPr>
           <a:xfrm>
-            <a:off x="4114800" y="4389120"/>
-            <a:ext cx="1371600" cy="1737360"/>
+            <a:off x="5059603" y="4389120"/>
+            <a:ext cx="2042083" cy="1737360"/>
           </a:xfrm>
           <a:prstGeom prst="roundRect">
             <a:avLst/>
@@ -8577,14 +8457,14 @@
       </p:sp>
       <p:sp>
         <p:nvSpPr>
-          <p:cNvPr id="25" name="TextBox 24"/>
+          <p:cNvPr id="24" name="TextBox 23"/>
           <p:cNvSpPr txBox="1"/>
           <p:nvPr/>
         </p:nvSpPr>
         <p:spPr>
           <a:xfrm>
-            <a:off x="4206240" y="4480559"/>
-            <a:ext cx="1188720" cy="1554480"/>
+            <a:off x="5151043" y="4480559"/>
+            <a:ext cx="1859203" cy="1554480"/>
           </a:xfrm>
           <a:prstGeom prst="rect">
             <a:avLst/>
@@ -8612,14 +8492,14 @@
       </p:sp>
       <p:sp>
         <p:nvSpPr>
-          <p:cNvPr id="26" name="Rounded Rectangle 25"/>
+          <p:cNvPr id="25" name="Rounded Rectangle 24"/>
           <p:cNvSpPr/>
           <p:nvPr/>
         </p:nvSpPr>
         <p:spPr>
           <a:xfrm>
-            <a:off x="5623560" y="4389120"/>
-            <a:ext cx="1371600" cy="1737360"/>
+            <a:off x="7238847" y="4389120"/>
+            <a:ext cx="2042083" cy="1737360"/>
           </a:xfrm>
           <a:prstGeom prst="roundRect">
             <a:avLst/>
@@ -8657,14 +8537,14 @@
       </p:sp>
       <p:sp>
         <p:nvSpPr>
-          <p:cNvPr id="27" name="TextBox 26"/>
+          <p:cNvPr id="26" name="TextBox 25"/>
           <p:cNvSpPr txBox="1"/>
           <p:nvPr/>
         </p:nvSpPr>
         <p:spPr>
           <a:xfrm>
-            <a:off x="5715000" y="4480559"/>
-            <a:ext cx="1188720" cy="1554480"/>
+            <a:off x="7330287" y="4480559"/>
+            <a:ext cx="1859203" cy="1554480"/>
           </a:xfrm>
           <a:prstGeom prst="rect">
             <a:avLst/>
@@ -8692,14 +8572,14 @@
       </p:sp>
       <p:sp>
         <p:nvSpPr>
-          <p:cNvPr id="28" name="Rounded Rectangle 27"/>
+          <p:cNvPr id="27" name="Rounded Rectangle 26"/>
           <p:cNvSpPr/>
           <p:nvPr/>
         </p:nvSpPr>
         <p:spPr>
           <a:xfrm>
-            <a:off x="7132319" y="4389120"/>
-            <a:ext cx="1371600" cy="1737360"/>
+            <a:off x="9418091" y="4389120"/>
+            <a:ext cx="2042083" cy="1737360"/>
           </a:xfrm>
           <a:prstGeom prst="roundRect">
             <a:avLst/>
@@ -8737,14 +8617,14 @@
       </p:sp>
       <p:sp>
         <p:nvSpPr>
-          <p:cNvPr id="29" name="TextBox 28"/>
+          <p:cNvPr id="28" name="TextBox 27"/>
           <p:cNvSpPr txBox="1"/>
           <p:nvPr/>
         </p:nvSpPr>
         <p:spPr>
           <a:xfrm>
-            <a:off x="7223759" y="4480559"/>
-            <a:ext cx="1188720" cy="1554480"/>
+            <a:off x="9509531" y="4480559"/>
+            <a:ext cx="1859203" cy="1554480"/>
           </a:xfrm>
           <a:prstGeom prst="rect">
             <a:avLst/>
@@ -8983,40 +8863,16 @@
           </a:p>
         </p:txBody>
       </p:sp>
-      <p:pic>
-        <p:nvPicPr>
-          <p:cNvPr id="7" name="Picture 6" descr="winter_melon_tea.jpg"/>
-          <p:cNvPicPr>
-            <a:picLocks noChangeAspect="1"/>
-          </p:cNvPicPr>
-          <p:nvPr/>
-        </p:nvPicPr>
-        <p:blipFill>
-          <a:blip r:embed="rId2"/>
-          <a:stretch>
-            <a:fillRect/>
-          </a:stretch>
-        </p:blipFill>
-        <p:spPr>
-          <a:xfrm>
-            <a:off x="9235440" y="1783080"/>
-            <a:ext cx="2194560" cy="4389120"/>
-          </a:xfrm>
-          <a:prstGeom prst="rect">
-            <a:avLst/>
-          </a:prstGeom>
-        </p:spPr>
-      </p:pic>
-      <p:sp>
-        <p:nvSpPr>
-          <p:cNvPr id="8" name="Rectangle 7"/>
+      <p:sp>
+        <p:nvSpPr>
+          <p:cNvPr id="7" name="Rectangle 6"/>
           <p:cNvSpPr/>
           <p:nvPr/>
         </p:nvSpPr>
         <p:spPr>
           <a:xfrm>
-            <a:off x="2423160" y="1783080"/>
-            <a:ext cx="3291840" cy="457200"/>
+            <a:off x="2880360" y="1783080"/>
+            <a:ext cx="4206240" cy="457200"/>
           </a:xfrm>
           <a:prstGeom prst="rect">
             <a:avLst/>
@@ -9061,14 +8917,14 @@
       </p:sp>
       <p:sp>
         <p:nvSpPr>
-          <p:cNvPr id="9" name="Rectangle 8"/>
+          <p:cNvPr id="8" name="Rectangle 7"/>
           <p:cNvSpPr/>
           <p:nvPr/>
         </p:nvSpPr>
         <p:spPr>
           <a:xfrm>
-            <a:off x="5852160" y="1783080"/>
-            <a:ext cx="3291840" cy="457200"/>
+            <a:off x="7223760" y="1783080"/>
+            <a:ext cx="4206240" cy="457200"/>
           </a:xfrm>
           <a:prstGeom prst="rect">
             <a:avLst/>
@@ -9113,14 +8969,14 @@
       </p:sp>
       <p:sp>
         <p:nvSpPr>
-          <p:cNvPr id="10" name="Rounded Rectangle 9"/>
+          <p:cNvPr id="9" name="Rounded Rectangle 8"/>
           <p:cNvSpPr/>
           <p:nvPr/>
         </p:nvSpPr>
         <p:spPr>
           <a:xfrm>
             <a:off x="731520" y="2377440"/>
-            <a:ext cx="1554480" cy="822960"/>
+            <a:ext cx="2011680" cy="868680"/>
           </a:xfrm>
           <a:prstGeom prst="roundRect">
             <a:avLst/>
@@ -9167,14 +9023,14 @@
       </p:sp>
       <p:sp>
         <p:nvSpPr>
-          <p:cNvPr id="11" name="Rounded Rectangle 10"/>
+          <p:cNvPr id="10" name="Rounded Rectangle 9"/>
           <p:cNvSpPr/>
           <p:nvPr/>
         </p:nvSpPr>
         <p:spPr>
           <a:xfrm>
-            <a:off x="2423160" y="2377440"/>
-            <a:ext cx="3291840" cy="822960"/>
+            <a:off x="2880360" y="2377440"/>
+            <a:ext cx="4206240" cy="868680"/>
           </a:xfrm>
           <a:prstGeom prst="roundRect">
             <a:avLst/>
@@ -9212,14 +9068,14 @@
       </p:sp>
       <p:sp>
         <p:nvSpPr>
-          <p:cNvPr id="12" name="TextBox 11"/>
+          <p:cNvPr id="11" name="TextBox 10"/>
           <p:cNvSpPr txBox="1"/>
           <p:nvPr/>
         </p:nvSpPr>
         <p:spPr>
           <a:xfrm>
-            <a:off x="2514600" y="2423160"/>
-            <a:ext cx="3108960" cy="731520"/>
+            <a:off x="2971800" y="2423160"/>
+            <a:ext cx="4023359" cy="777240"/>
           </a:xfrm>
           <a:prstGeom prst="rect">
             <a:avLst/>
@@ -9247,14 +9103,14 @@
       </p:sp>
       <p:sp>
         <p:nvSpPr>
-          <p:cNvPr id="13" name="Rounded Rectangle 12"/>
+          <p:cNvPr id="12" name="Rounded Rectangle 11"/>
           <p:cNvSpPr/>
           <p:nvPr/>
         </p:nvSpPr>
         <p:spPr>
           <a:xfrm>
-            <a:off x="5852160" y="2377440"/>
-            <a:ext cx="3291840" cy="822960"/>
+            <a:off x="7223760" y="2377440"/>
+            <a:ext cx="4206240" cy="868680"/>
           </a:xfrm>
           <a:prstGeom prst="roundRect">
             <a:avLst/>
@@ -9292,14 +9148,14 @@
       </p:sp>
       <p:sp>
         <p:nvSpPr>
-          <p:cNvPr id="14" name="TextBox 13"/>
+          <p:cNvPr id="13" name="TextBox 12"/>
           <p:cNvSpPr txBox="1"/>
           <p:nvPr/>
         </p:nvSpPr>
         <p:spPr>
           <a:xfrm>
-            <a:off x="5943600" y="2423160"/>
-            <a:ext cx="3108960" cy="731520"/>
+            <a:off x="7315200" y="2423160"/>
+            <a:ext cx="4023359" cy="777240"/>
           </a:xfrm>
           <a:prstGeom prst="rect">
             <a:avLst/>
@@ -9327,14 +9183,14 @@
       </p:sp>
       <p:sp>
         <p:nvSpPr>
-          <p:cNvPr id="15" name="Rounded Rectangle 14"/>
+          <p:cNvPr id="14" name="Rounded Rectangle 13"/>
           <p:cNvSpPr/>
           <p:nvPr/>
         </p:nvSpPr>
         <p:spPr>
           <a:xfrm>
-            <a:off x="731520" y="3291840"/>
-            <a:ext cx="1554480" cy="822960"/>
+            <a:off x="731520" y="3337560"/>
+            <a:ext cx="2011680" cy="868680"/>
           </a:xfrm>
           <a:prstGeom prst="roundRect">
             <a:avLst/>
@@ -9381,14 +9237,14 @@
       </p:sp>
       <p:sp>
         <p:nvSpPr>
-          <p:cNvPr id="16" name="Rounded Rectangle 15"/>
+          <p:cNvPr id="15" name="Rounded Rectangle 14"/>
           <p:cNvSpPr/>
           <p:nvPr/>
         </p:nvSpPr>
         <p:spPr>
           <a:xfrm>
-            <a:off x="2423160" y="3291840"/>
-            <a:ext cx="3291840" cy="822960"/>
+            <a:off x="2880360" y="3337560"/>
+            <a:ext cx="4206240" cy="868680"/>
           </a:xfrm>
           <a:prstGeom prst="roundRect">
             <a:avLst/>
@@ -9426,14 +9282,14 @@
       </p:sp>
       <p:sp>
         <p:nvSpPr>
-          <p:cNvPr id="17" name="TextBox 16"/>
+          <p:cNvPr id="16" name="TextBox 15"/>
           <p:cNvSpPr txBox="1"/>
           <p:nvPr/>
         </p:nvSpPr>
         <p:spPr>
           <a:xfrm>
-            <a:off x="2514600" y="3337560"/>
-            <a:ext cx="3108960" cy="731520"/>
+            <a:off x="2971800" y="3383280"/>
+            <a:ext cx="4023359" cy="777240"/>
           </a:xfrm>
           <a:prstGeom prst="rect">
             <a:avLst/>
@@ -9461,14 +9317,14 @@
       </p:sp>
       <p:sp>
         <p:nvSpPr>
-          <p:cNvPr id="18" name="Rounded Rectangle 17"/>
+          <p:cNvPr id="17" name="Rounded Rectangle 16"/>
           <p:cNvSpPr/>
           <p:nvPr/>
         </p:nvSpPr>
         <p:spPr>
           <a:xfrm>
-            <a:off x="5852160" y="3291840"/>
-            <a:ext cx="3291840" cy="822960"/>
+            <a:off x="7223760" y="3337560"/>
+            <a:ext cx="4206240" cy="868680"/>
           </a:xfrm>
           <a:prstGeom prst="roundRect">
             <a:avLst/>
@@ -9506,14 +9362,14 @@
       </p:sp>
       <p:sp>
         <p:nvSpPr>
-          <p:cNvPr id="19" name="TextBox 18"/>
+          <p:cNvPr id="18" name="TextBox 17"/>
           <p:cNvSpPr txBox="1"/>
           <p:nvPr/>
         </p:nvSpPr>
         <p:spPr>
           <a:xfrm>
-            <a:off x="5943600" y="3337560"/>
-            <a:ext cx="3108960" cy="731520"/>
+            <a:off x="7315200" y="3383280"/>
+            <a:ext cx="4023359" cy="777240"/>
           </a:xfrm>
           <a:prstGeom prst="rect">
             <a:avLst/>
@@ -9541,14 +9397,14 @@
       </p:sp>
       <p:sp>
         <p:nvSpPr>
-          <p:cNvPr id="20" name="Rounded Rectangle 19"/>
+          <p:cNvPr id="19" name="Rounded Rectangle 18"/>
           <p:cNvSpPr/>
           <p:nvPr/>
         </p:nvSpPr>
         <p:spPr>
           <a:xfrm>
-            <a:off x="731520" y="4206240"/>
-            <a:ext cx="1554480" cy="822960"/>
+            <a:off x="731520" y="4297680"/>
+            <a:ext cx="2011680" cy="868680"/>
           </a:xfrm>
           <a:prstGeom prst="roundRect">
             <a:avLst/>
@@ -9595,14 +9451,14 @@
       </p:sp>
       <p:sp>
         <p:nvSpPr>
-          <p:cNvPr id="21" name="Rounded Rectangle 20"/>
+          <p:cNvPr id="20" name="Rounded Rectangle 19"/>
           <p:cNvSpPr/>
           <p:nvPr/>
         </p:nvSpPr>
         <p:spPr>
           <a:xfrm>
-            <a:off x="2423160" y="4206240"/>
-            <a:ext cx="3291840" cy="822960"/>
+            <a:off x="2880360" y="4297680"/>
+            <a:ext cx="4206240" cy="868680"/>
           </a:xfrm>
           <a:prstGeom prst="roundRect">
             <a:avLst/>
@@ -9640,14 +9496,14 @@
       </p:sp>
       <p:sp>
         <p:nvSpPr>
-          <p:cNvPr id="22" name="TextBox 21"/>
+          <p:cNvPr id="21" name="TextBox 20"/>
           <p:cNvSpPr txBox="1"/>
           <p:nvPr/>
         </p:nvSpPr>
         <p:spPr>
           <a:xfrm>
-            <a:off x="2514600" y="4251959"/>
-            <a:ext cx="3108960" cy="731520"/>
+            <a:off x="2971800" y="4343400"/>
+            <a:ext cx="4023359" cy="777240"/>
           </a:xfrm>
           <a:prstGeom prst="rect">
             <a:avLst/>
@@ -9675,14 +9531,14 @@
       </p:sp>
       <p:sp>
         <p:nvSpPr>
-          <p:cNvPr id="23" name="Rounded Rectangle 22"/>
+          <p:cNvPr id="22" name="Rounded Rectangle 21"/>
           <p:cNvSpPr/>
           <p:nvPr/>
         </p:nvSpPr>
         <p:spPr>
           <a:xfrm>
-            <a:off x="5852160" y="4206240"/>
-            <a:ext cx="3291840" cy="822960"/>
+            <a:off x="7223760" y="4297680"/>
+            <a:ext cx="4206240" cy="868680"/>
           </a:xfrm>
           <a:prstGeom prst="roundRect">
             <a:avLst/>
@@ -9720,14 +9576,14 @@
       </p:sp>
       <p:sp>
         <p:nvSpPr>
-          <p:cNvPr id="24" name="TextBox 23"/>
+          <p:cNvPr id="23" name="TextBox 22"/>
           <p:cNvSpPr txBox="1"/>
           <p:nvPr/>
         </p:nvSpPr>
         <p:spPr>
           <a:xfrm>
-            <a:off x="5943600" y="4251959"/>
-            <a:ext cx="3108960" cy="731520"/>
+            <a:off x="7315200" y="4343400"/>
+            <a:ext cx="4023359" cy="777240"/>
           </a:xfrm>
           <a:prstGeom prst="rect">
             <a:avLst/>
@@ -9755,14 +9611,14 @@
       </p:sp>
       <p:sp>
         <p:nvSpPr>
-          <p:cNvPr id="25" name="Rounded Rectangle 24"/>
+          <p:cNvPr id="24" name="Rounded Rectangle 23"/>
           <p:cNvSpPr/>
           <p:nvPr/>
         </p:nvSpPr>
         <p:spPr>
           <a:xfrm>
-            <a:off x="731520" y="5120640"/>
-            <a:ext cx="1554480" cy="822960"/>
+            <a:off x="731520" y="5257800"/>
+            <a:ext cx="2011680" cy="868680"/>
           </a:xfrm>
           <a:prstGeom prst="roundRect">
             <a:avLst/>
@@ -9809,14 +9665,14 @@
       </p:sp>
       <p:sp>
         <p:nvSpPr>
-          <p:cNvPr id="26" name="Rounded Rectangle 25"/>
+          <p:cNvPr id="25" name="Rounded Rectangle 24"/>
           <p:cNvSpPr/>
           <p:nvPr/>
         </p:nvSpPr>
         <p:spPr>
           <a:xfrm>
-            <a:off x="2423160" y="5120640"/>
-            <a:ext cx="3291840" cy="822960"/>
+            <a:off x="2880360" y="5257800"/>
+            <a:ext cx="4206240" cy="868680"/>
           </a:xfrm>
           <a:prstGeom prst="roundRect">
             <a:avLst/>
@@ -9854,14 +9710,14 @@
       </p:sp>
       <p:sp>
         <p:nvSpPr>
-          <p:cNvPr id="27" name="TextBox 26"/>
+          <p:cNvPr id="26" name="TextBox 25"/>
           <p:cNvSpPr txBox="1"/>
           <p:nvPr/>
         </p:nvSpPr>
         <p:spPr>
           <a:xfrm>
-            <a:off x="2514600" y="5166359"/>
-            <a:ext cx="3108960" cy="731520"/>
+            <a:off x="2971800" y="5303520"/>
+            <a:ext cx="4023359" cy="777240"/>
           </a:xfrm>
           <a:prstGeom prst="rect">
             <a:avLst/>
@@ -9889,14 +9745,14 @@
       </p:sp>
       <p:sp>
         <p:nvSpPr>
-          <p:cNvPr id="28" name="Rounded Rectangle 27"/>
+          <p:cNvPr id="27" name="Rounded Rectangle 26"/>
           <p:cNvSpPr/>
           <p:nvPr/>
         </p:nvSpPr>
         <p:spPr>
           <a:xfrm>
-            <a:off x="5852160" y="5120640"/>
-            <a:ext cx="3291840" cy="822960"/>
+            <a:off x="7223760" y="5257800"/>
+            <a:ext cx="4206240" cy="868680"/>
           </a:xfrm>
           <a:prstGeom prst="roundRect">
             <a:avLst/>
@@ -9934,14 +9790,14 @@
       </p:sp>
       <p:sp>
         <p:nvSpPr>
-          <p:cNvPr id="29" name="TextBox 28"/>
+          <p:cNvPr id="28" name="TextBox 27"/>
           <p:cNvSpPr txBox="1"/>
           <p:nvPr/>
         </p:nvSpPr>
         <p:spPr>
           <a:xfrm>
-            <a:off x="5943600" y="5166359"/>
-            <a:ext cx="3108960" cy="731520"/>
+            <a:off x="7315200" y="5303520"/>
+            <a:ext cx="4023359" cy="777240"/>
           </a:xfrm>
           <a:prstGeom prst="rect">
             <a:avLst/>
@@ -10180,40 +10036,16 @@
           </a:p>
         </p:txBody>
       </p:sp>
-      <p:pic>
-        <p:nvPicPr>
-          <p:cNvPr id="7" name="Picture 6" descr="rice_noodles.jpg"/>
-          <p:cNvPicPr>
-            <a:picLocks noChangeAspect="1"/>
-          </p:cNvPicPr>
-          <p:nvPr/>
-        </p:nvPicPr>
-        <p:blipFill>
-          <a:blip r:embed="rId2"/>
-          <a:stretch>
-            <a:fillRect/>
-          </a:stretch>
-        </p:blipFill>
-        <p:spPr>
-          <a:xfrm>
-            <a:off x="8595360" y="1828800"/>
-            <a:ext cx="2834640" cy="4389120"/>
-          </a:xfrm>
-          <a:prstGeom prst="rect">
-            <a:avLst/>
-          </a:prstGeom>
-        </p:spPr>
-      </p:pic>
-      <p:sp>
-        <p:nvSpPr>
-          <p:cNvPr id="8" name="Rounded Rectangle 7"/>
+      <p:sp>
+        <p:nvSpPr>
+          <p:cNvPr id="7" name="Rounded Rectangle 6"/>
           <p:cNvSpPr/>
           <p:nvPr/>
         </p:nvSpPr>
         <p:spPr>
           <a:xfrm>
             <a:off x="731520" y="1828800"/>
-            <a:ext cx="2438400" cy="4389120"/>
+            <a:ext cx="3423818" cy="4389120"/>
           </a:xfrm>
           <a:prstGeom prst="roundRect">
             <a:avLst/>
@@ -10251,14 +10083,14 @@
       </p:sp>
       <p:sp>
         <p:nvSpPr>
-          <p:cNvPr id="9" name="Rectangle 8"/>
+          <p:cNvPr id="8" name="Rectangle 7"/>
           <p:cNvSpPr/>
           <p:nvPr/>
         </p:nvSpPr>
         <p:spPr>
           <a:xfrm>
             <a:off x="731520" y="1828800"/>
-            <a:ext cx="2438400" cy="457200"/>
+            <a:ext cx="3423818" cy="457200"/>
           </a:xfrm>
           <a:prstGeom prst="rect">
             <a:avLst/>
@@ -10303,14 +10135,14 @@
       </p:sp>
       <p:sp>
         <p:nvSpPr>
-          <p:cNvPr id="10" name="TextBox 9"/>
+          <p:cNvPr id="9" name="TextBox 8"/>
           <p:cNvSpPr txBox="1"/>
           <p:nvPr/>
         </p:nvSpPr>
         <p:spPr>
           <a:xfrm>
             <a:off x="868680" y="2423160"/>
-            <a:ext cx="2164080" cy="3657600"/>
+            <a:ext cx="3149498" cy="3657600"/>
           </a:xfrm>
           <a:prstGeom prst="rect">
             <a:avLst/>
@@ -10371,14 +10203,14 @@
       </p:sp>
       <p:sp>
         <p:nvSpPr>
-          <p:cNvPr id="11" name="Rounded Rectangle 10"/>
+          <p:cNvPr id="10" name="Rounded Rectangle 9"/>
           <p:cNvSpPr/>
           <p:nvPr/>
         </p:nvSpPr>
         <p:spPr>
           <a:xfrm>
-            <a:off x="3352800" y="1828800"/>
-            <a:ext cx="2438400" cy="4389120"/>
+            <a:off x="4383938" y="1828800"/>
+            <a:ext cx="3423818" cy="4389120"/>
           </a:xfrm>
           <a:prstGeom prst="roundRect">
             <a:avLst/>
@@ -10416,14 +10248,14 @@
       </p:sp>
       <p:sp>
         <p:nvSpPr>
-          <p:cNvPr id="12" name="Rectangle 11"/>
+          <p:cNvPr id="11" name="Rectangle 10"/>
           <p:cNvSpPr/>
           <p:nvPr/>
         </p:nvSpPr>
         <p:spPr>
           <a:xfrm>
-            <a:off x="3352800" y="1828800"/>
-            <a:ext cx="2438400" cy="457200"/>
+            <a:off x="4383938" y="1828800"/>
+            <a:ext cx="3423818" cy="457200"/>
           </a:xfrm>
           <a:prstGeom prst="rect">
             <a:avLst/>
@@ -10468,14 +10300,14 @@
       </p:sp>
       <p:sp>
         <p:nvSpPr>
-          <p:cNvPr id="13" name="TextBox 12"/>
+          <p:cNvPr id="12" name="TextBox 11"/>
           <p:cNvSpPr txBox="1"/>
           <p:nvPr/>
         </p:nvSpPr>
         <p:spPr>
           <a:xfrm>
-            <a:off x="3489960" y="2423160"/>
-            <a:ext cx="2164080" cy="3657600"/>
+            <a:off x="4521098" y="2423160"/>
+            <a:ext cx="3149498" cy="3657600"/>
           </a:xfrm>
           <a:prstGeom prst="rect">
             <a:avLst/>
@@ -10536,14 +10368,14 @@
       </p:sp>
       <p:sp>
         <p:nvSpPr>
-          <p:cNvPr id="14" name="Rounded Rectangle 13"/>
+          <p:cNvPr id="13" name="Rounded Rectangle 12"/>
           <p:cNvSpPr/>
           <p:nvPr/>
         </p:nvSpPr>
         <p:spPr>
           <a:xfrm>
-            <a:off x="5974080" y="1828800"/>
-            <a:ext cx="2438400" cy="4389120"/>
+            <a:off x="8036356" y="1828800"/>
+            <a:ext cx="3423818" cy="4389120"/>
           </a:xfrm>
           <a:prstGeom prst="roundRect">
             <a:avLst/>
@@ -10581,14 +10413,14 @@
       </p:sp>
       <p:sp>
         <p:nvSpPr>
-          <p:cNvPr id="15" name="Rectangle 14"/>
+          <p:cNvPr id="14" name="Rectangle 13"/>
           <p:cNvSpPr/>
           <p:nvPr/>
         </p:nvSpPr>
         <p:spPr>
           <a:xfrm>
-            <a:off x="5974080" y="1828800"/>
-            <a:ext cx="2438400" cy="457200"/>
+            <a:off x="8036356" y="1828800"/>
+            <a:ext cx="3423818" cy="457200"/>
           </a:xfrm>
           <a:prstGeom prst="rect">
             <a:avLst/>
@@ -10633,14 +10465,14 @@
       </p:sp>
       <p:sp>
         <p:nvSpPr>
-          <p:cNvPr id="16" name="TextBox 15"/>
+          <p:cNvPr id="15" name="TextBox 14"/>
           <p:cNvSpPr txBox="1"/>
           <p:nvPr/>
         </p:nvSpPr>
         <p:spPr>
           <a:xfrm>
-            <a:off x="6111240" y="2423160"/>
-            <a:ext cx="2164080" cy="3657600"/>
+            <a:off x="8173516" y="2423160"/>
+            <a:ext cx="3149498" cy="3657600"/>
           </a:xfrm>
           <a:prstGeom prst="rect">
             <a:avLst/>
@@ -10921,7 +10753,7 @@
         <p:spPr>
           <a:xfrm>
             <a:off x="731520" y="1783080"/>
-            <a:ext cx="1188720" cy="3931920"/>
+            <a:ext cx="1097280" cy="3931920"/>
           </a:xfrm>
           <a:prstGeom prst="rect">
             <a:avLst/>
@@ -11037,8 +10869,8 @@
         </p:nvSpPr>
         <p:spPr>
           <a:xfrm>
-            <a:off x="2103120" y="5806440"/>
-            <a:ext cx="6858000" cy="384048"/>
+            <a:off x="1965960" y="5806440"/>
+            <a:ext cx="6583680" cy="384048"/>
           </a:xfrm>
           <a:prstGeom prst="rect">
             <a:avLst/>
@@ -11066,7 +10898,7 @@
           <a:lstStyle/>
           <a:p>
             <a:pPr algn="ctr">
-              <a:defRPr sz="1100" b="1">
+              <a:defRPr sz="1050" b="1">
                 <a:solidFill>
                   <a:srgbClr val="FFFFFF"/>
                 </a:solidFill>
@@ -11078,40 +10910,16 @@
           </a:p>
         </p:txBody>
       </p:sp>
-      <p:pic>
-        <p:nvPicPr>
-          <p:cNvPr id="9" name="Picture 8" descr="yang_shuangzi.jpg"/>
-          <p:cNvPicPr>
-            <a:picLocks noChangeAspect="1"/>
-          </p:cNvPicPr>
-          <p:nvPr/>
-        </p:nvPicPr>
-        <p:blipFill>
-          <a:blip r:embed="rId2"/>
-          <a:stretch>
-            <a:fillRect/>
-          </a:stretch>
-        </p:blipFill>
-        <p:spPr>
-          <a:xfrm>
-            <a:off x="9235440" y="1783080"/>
-            <a:ext cx="2194560" cy="4389120"/>
-          </a:xfrm>
-          <a:prstGeom prst="rect">
-            <a:avLst/>
-          </a:prstGeom>
-        </p:spPr>
-      </p:pic>
-      <p:sp>
-        <p:nvSpPr>
-          <p:cNvPr id="10" name="Rounded Rectangle 9"/>
+      <p:sp>
+        <p:nvSpPr>
+          <p:cNvPr id="9" name="Rounded Rectangle 8"/>
           <p:cNvSpPr/>
           <p:nvPr/>
         </p:nvSpPr>
         <p:spPr>
           <a:xfrm>
-            <a:off x="2103120" y="1783080"/>
-            <a:ext cx="3337560" cy="1874519"/>
+            <a:off x="1965960" y="1783080"/>
+            <a:ext cx="3246120" cy="1874519"/>
           </a:xfrm>
           <a:prstGeom prst="roundRect">
             <a:avLst/>
@@ -11149,14 +10957,14 @@
       </p:sp>
       <p:sp>
         <p:nvSpPr>
-          <p:cNvPr id="11" name="TextBox 10"/>
+          <p:cNvPr id="10" name="TextBox 9"/>
           <p:cNvSpPr txBox="1"/>
           <p:nvPr/>
         </p:nvSpPr>
         <p:spPr>
           <a:xfrm>
-            <a:off x="2240279" y="1874519"/>
-            <a:ext cx="3063240" cy="1691639"/>
+            <a:off x="2103120" y="1874519"/>
+            <a:ext cx="2971800" cy="1691639"/>
           </a:xfrm>
           <a:prstGeom prst="rect">
             <a:avLst/>
@@ -11199,14 +11007,14 @@
       </p:sp>
       <p:sp>
         <p:nvSpPr>
-          <p:cNvPr id="12" name="Rounded Rectangle 11"/>
+          <p:cNvPr id="11" name="Rounded Rectangle 10"/>
           <p:cNvSpPr/>
           <p:nvPr/>
         </p:nvSpPr>
         <p:spPr>
           <a:xfrm>
-            <a:off x="5577840" y="1783080"/>
-            <a:ext cx="3337560" cy="1874519"/>
+            <a:off x="5303520" y="1783080"/>
+            <a:ext cx="3246120" cy="1874519"/>
           </a:xfrm>
           <a:prstGeom prst="roundRect">
             <a:avLst/>
@@ -11244,14 +11052,14 @@
       </p:sp>
       <p:sp>
         <p:nvSpPr>
-          <p:cNvPr id="13" name="TextBox 12"/>
+          <p:cNvPr id="12" name="TextBox 11"/>
           <p:cNvSpPr txBox="1"/>
           <p:nvPr/>
         </p:nvSpPr>
         <p:spPr>
           <a:xfrm>
-            <a:off x="5715000" y="1874519"/>
-            <a:ext cx="3063240" cy="1691639"/>
+            <a:off x="5440680" y="1874519"/>
+            <a:ext cx="2971800" cy="1691639"/>
           </a:xfrm>
           <a:prstGeom prst="rect">
             <a:avLst/>
@@ -11294,14 +11102,14 @@
       </p:sp>
       <p:sp>
         <p:nvSpPr>
-          <p:cNvPr id="14" name="Rounded Rectangle 13"/>
+          <p:cNvPr id="13" name="Rounded Rectangle 12"/>
           <p:cNvSpPr/>
           <p:nvPr/>
         </p:nvSpPr>
         <p:spPr>
           <a:xfrm>
-            <a:off x="2103120" y="3794760"/>
-            <a:ext cx="3337560" cy="1874519"/>
+            <a:off x="1965960" y="3794760"/>
+            <a:ext cx="3246120" cy="1874519"/>
           </a:xfrm>
           <a:prstGeom prst="roundRect">
             <a:avLst/>
@@ -11339,14 +11147,14 @@
       </p:sp>
       <p:sp>
         <p:nvSpPr>
-          <p:cNvPr id="15" name="TextBox 14"/>
+          <p:cNvPr id="14" name="TextBox 13"/>
           <p:cNvSpPr txBox="1"/>
           <p:nvPr/>
         </p:nvSpPr>
         <p:spPr>
           <a:xfrm>
-            <a:off x="2240279" y="3886200"/>
-            <a:ext cx="3063240" cy="1691639"/>
+            <a:off x="2103120" y="3886200"/>
+            <a:ext cx="2971800" cy="1691639"/>
           </a:xfrm>
           <a:prstGeom prst="rect">
             <a:avLst/>
@@ -11389,14 +11197,14 @@
       </p:sp>
       <p:sp>
         <p:nvSpPr>
-          <p:cNvPr id="16" name="Rounded Rectangle 15"/>
+          <p:cNvPr id="15" name="Rounded Rectangle 14"/>
           <p:cNvSpPr/>
           <p:nvPr/>
         </p:nvSpPr>
         <p:spPr>
           <a:xfrm>
-            <a:off x="5577840" y="3794760"/>
-            <a:ext cx="3337560" cy="1874519"/>
+            <a:off x="5303520" y="3794760"/>
+            <a:ext cx="3246120" cy="1874519"/>
           </a:xfrm>
           <a:prstGeom prst="roundRect">
             <a:avLst/>
@@ -11434,14 +11242,14 @@
       </p:sp>
       <p:sp>
         <p:nvSpPr>
-          <p:cNvPr id="17" name="TextBox 16"/>
+          <p:cNvPr id="16" name="TextBox 15"/>
           <p:cNvSpPr txBox="1"/>
           <p:nvPr/>
         </p:nvSpPr>
         <p:spPr>
           <a:xfrm>
-            <a:off x="5715000" y="3886200"/>
-            <a:ext cx="3063240" cy="1691639"/>
+            <a:off x="5440680" y="3886200"/>
+            <a:ext cx="2971800" cy="1691639"/>
           </a:xfrm>
           <a:prstGeom prst="rect">
             <a:avLst/>
@@ -11478,6 +11286,134 @@
             </a:pPr>
             <a:r>
               <a:t>具備快節奏大眾娛樂性，但欠缺歷史厚度與思想承載量</a:t>
+            </a:r>
+          </a:p>
+        </p:txBody>
+      </p:sp>
+      <p:sp>
+        <p:nvSpPr>
+          <p:cNvPr id="17" name="Rounded Rectangle 16"/>
+          <p:cNvSpPr/>
+          <p:nvPr/>
+        </p:nvSpPr>
+        <p:spPr>
+          <a:xfrm>
+            <a:off x="8778240" y="1783080"/>
+            <a:ext cx="2651760" cy="4389120"/>
+          </a:xfrm>
+          <a:prstGeom prst="roundRect">
+            <a:avLst/>
+          </a:prstGeom>
+          <a:solidFill>
+            <a:srgbClr val="F3F4F6"/>
+          </a:solidFill>
+          <a:ln w="19050">
+            <a:solidFill>
+              <a:srgbClr val="177B57"/>
+            </a:solidFill>
+          </a:ln>
+        </p:spPr>
+        <p:style>
+          <a:lnRef idx="1">
+            <a:schemeClr val="accent1"/>
+          </a:lnRef>
+          <a:fillRef idx="3">
+            <a:schemeClr val="accent1"/>
+          </a:fillRef>
+          <a:effectRef idx="2">
+            <a:schemeClr val="accent1"/>
+          </a:effectRef>
+          <a:fontRef idx="minor">
+            <a:schemeClr val="lt1"/>
+          </a:fontRef>
+        </p:style>
+        <p:txBody>
+          <a:bodyPr rtlCol="0" anchor="ctr"/>
+          <a:lstStyle/>
+          <a:p>
+            <a:pPr algn="ctr"/>
+          </a:p>
+        </p:txBody>
+      </p:sp>
+      <p:sp>
+        <p:nvSpPr>
+          <p:cNvPr id="18" name="TextBox 17"/>
+          <p:cNvSpPr txBox="1"/>
+          <p:nvPr/>
+        </p:nvSpPr>
+        <p:spPr>
+          <a:xfrm>
+            <a:off x="8915400" y="1920240"/>
+            <a:ext cx="2377440" cy="4114800"/>
+          </a:xfrm>
+          <a:prstGeom prst="rect">
+            <a:avLst/>
+          </a:prstGeom>
+          <a:noFill/>
+        </p:spPr>
+        <p:txBody>
+          <a:bodyPr wrap="square">
+            <a:spAutoFit/>
+          </a:bodyPr>
+          <a:lstStyle/>
+          <a:p>
+            <a:pPr>
+              <a:spcAft>
+                <a:spcPts val="800"/>
+              </a:spcAft>
+              <a:defRPr sz="1400" b="1">
+                <a:solidFill>
+                  <a:srgbClr val="177B57"/>
+                </a:solidFill>
+              </a:defRPr>
+            </a:pPr>
+            <a:r>
+              <a:t>🎯 BCG 策略啟示</a:t>
+            </a:r>
+          </a:p>
+          <a:p>
+            <a:pPr>
+              <a:spcAft>
+                <a:spcPts val="800"/>
+              </a:spcAft>
+              <a:defRPr sz="1100">
+                <a:solidFill>
+                  <a:srgbClr val="1F2937"/>
+                </a:solidFill>
+              </a:defRPr>
+            </a:pPr>
+            <a:r>
+              <a:t>• 【雙重平衡】不走極端學術晦澀，亦不流於快餐膚淺。</a:t>
+            </a:r>
+          </a:p>
+          <a:p>
+            <a:pPr>
+              <a:spcAft>
+                <a:spcPts val="800"/>
+              </a:spcAft>
+              <a:defRPr sz="1100">
+                <a:solidFill>
+                  <a:srgbClr val="1F2937"/>
+                </a:solidFill>
+              </a:defRPr>
+            </a:pPr>
+            <a:r>
+              <a:t>• 【國際破圈】以大眾百合小說為載體，包覆深刻後殖民反思。</a:t>
+            </a:r>
+          </a:p>
+          <a:p>
+            <a:pPr>
+              <a:spcAft>
+                <a:spcPts val="800"/>
+              </a:spcAft>
+              <a:defRPr sz="1100">
+                <a:solidFill>
+                  <a:srgbClr val="1F2937"/>
+                </a:solidFill>
+              </a:defRPr>
+            </a:pPr>
+            <a:r>
+              <a:t>• 【出海範式】為臺灣在地經驗走向全球提供可複製的經典路徑。</a:t>
             </a:r>
           </a:p>
         </p:txBody>
@@ -11695,40 +11631,16 @@
           </a:p>
         </p:txBody>
       </p:sp>
-      <p:pic>
-        <p:nvPicPr>
-          <p:cNvPr id="7" name="Picture 6" descr="readers_community.jpg"/>
-          <p:cNvPicPr>
-            <a:picLocks noChangeAspect="1"/>
-          </p:cNvPicPr>
-          <p:nvPr/>
-        </p:nvPicPr>
-        <p:blipFill>
-          <a:blip r:embed="rId2"/>
-          <a:stretch>
-            <a:fillRect/>
-          </a:stretch>
-        </p:blipFill>
-        <p:spPr>
-          <a:xfrm>
-            <a:off x="8595360" y="1828800"/>
-            <a:ext cx="2834640" cy="4389120"/>
-          </a:xfrm>
-          <a:prstGeom prst="rect">
-            <a:avLst/>
-          </a:prstGeom>
-        </p:spPr>
-      </p:pic>
-      <p:sp>
-        <p:nvSpPr>
-          <p:cNvPr id="8" name="Rounded Rectangle 7"/>
+      <p:sp>
+        <p:nvSpPr>
+          <p:cNvPr id="7" name="Rounded Rectangle 6"/>
           <p:cNvSpPr/>
           <p:nvPr/>
         </p:nvSpPr>
         <p:spPr>
           <a:xfrm>
             <a:off x="731520" y="1828800"/>
-            <a:ext cx="2438400" cy="4389120"/>
+            <a:ext cx="3423818" cy="4389120"/>
           </a:xfrm>
           <a:prstGeom prst="roundRect">
             <a:avLst/>
@@ -11766,14 +11678,14 @@
       </p:sp>
       <p:sp>
         <p:nvSpPr>
-          <p:cNvPr id="9" name="Rectangle 8"/>
+          <p:cNvPr id="8" name="Rectangle 7"/>
           <p:cNvSpPr/>
           <p:nvPr/>
         </p:nvSpPr>
         <p:spPr>
           <a:xfrm>
             <a:off x="731520" y="1828800"/>
-            <a:ext cx="2438400" cy="457200"/>
+            <a:ext cx="3423818" cy="457200"/>
           </a:xfrm>
           <a:prstGeom prst="rect">
             <a:avLst/>
@@ -11818,14 +11730,14 @@
       </p:sp>
       <p:sp>
         <p:nvSpPr>
-          <p:cNvPr id="10" name="TextBox 9"/>
+          <p:cNvPr id="9" name="TextBox 8"/>
           <p:cNvSpPr txBox="1"/>
           <p:nvPr/>
         </p:nvSpPr>
         <p:spPr>
           <a:xfrm>
             <a:off x="868680" y="2423160"/>
-            <a:ext cx="2164080" cy="3657600"/>
+            <a:ext cx="3149498" cy="3657600"/>
           </a:xfrm>
           <a:prstGeom prst="rect">
             <a:avLst/>
@@ -11886,14 +11798,14 @@
       </p:sp>
       <p:sp>
         <p:nvSpPr>
-          <p:cNvPr id="11" name="Rounded Rectangle 10"/>
+          <p:cNvPr id="10" name="Rounded Rectangle 9"/>
           <p:cNvSpPr/>
           <p:nvPr/>
         </p:nvSpPr>
         <p:spPr>
           <a:xfrm>
-            <a:off x="3352800" y="1828800"/>
-            <a:ext cx="2438400" cy="4389120"/>
+            <a:off x="4383938" y="1828800"/>
+            <a:ext cx="3423818" cy="4389120"/>
           </a:xfrm>
           <a:prstGeom prst="roundRect">
             <a:avLst/>
@@ -11931,14 +11843,14 @@
       </p:sp>
       <p:sp>
         <p:nvSpPr>
-          <p:cNvPr id="12" name="Rectangle 11"/>
+          <p:cNvPr id="11" name="Rectangle 10"/>
           <p:cNvSpPr/>
           <p:nvPr/>
         </p:nvSpPr>
         <p:spPr>
           <a:xfrm>
-            <a:off x="3352800" y="1828800"/>
-            <a:ext cx="2438400" cy="457200"/>
+            <a:off x="4383938" y="1828800"/>
+            <a:ext cx="3423818" cy="457200"/>
           </a:xfrm>
           <a:prstGeom prst="rect">
             <a:avLst/>
@@ -11983,14 +11895,14 @@
       </p:sp>
       <p:sp>
         <p:nvSpPr>
-          <p:cNvPr id="13" name="TextBox 12"/>
+          <p:cNvPr id="12" name="TextBox 11"/>
           <p:cNvSpPr txBox="1"/>
           <p:nvPr/>
         </p:nvSpPr>
         <p:spPr>
           <a:xfrm>
-            <a:off x="3489960" y="2423160"/>
-            <a:ext cx="2164080" cy="3657600"/>
+            <a:off x="4521098" y="2423160"/>
+            <a:ext cx="3149498" cy="3657600"/>
           </a:xfrm>
           <a:prstGeom prst="rect">
             <a:avLst/>
@@ -12051,14 +11963,14 @@
       </p:sp>
       <p:sp>
         <p:nvSpPr>
-          <p:cNvPr id="14" name="Rounded Rectangle 13"/>
+          <p:cNvPr id="13" name="Rounded Rectangle 12"/>
           <p:cNvSpPr/>
           <p:nvPr/>
         </p:nvSpPr>
         <p:spPr>
           <a:xfrm>
-            <a:off x="5974080" y="1828800"/>
-            <a:ext cx="2438400" cy="4389120"/>
+            <a:off x="8036356" y="1828800"/>
+            <a:ext cx="3423818" cy="4389120"/>
           </a:xfrm>
           <a:prstGeom prst="roundRect">
             <a:avLst/>
@@ -12096,14 +12008,14 @@
       </p:sp>
       <p:sp>
         <p:nvSpPr>
-          <p:cNvPr id="15" name="Rectangle 14"/>
+          <p:cNvPr id="14" name="Rectangle 13"/>
           <p:cNvSpPr/>
           <p:nvPr/>
         </p:nvSpPr>
         <p:spPr>
           <a:xfrm>
-            <a:off x="5974080" y="1828800"/>
-            <a:ext cx="2438400" cy="457200"/>
+            <a:off x="8036356" y="1828800"/>
+            <a:ext cx="3423818" cy="457200"/>
           </a:xfrm>
           <a:prstGeom prst="rect">
             <a:avLst/>
@@ -12148,14 +12060,14 @@
       </p:sp>
       <p:sp>
         <p:nvSpPr>
-          <p:cNvPr id="16" name="TextBox 15"/>
+          <p:cNvPr id="15" name="TextBox 14"/>
           <p:cNvSpPr txBox="1"/>
           <p:nvPr/>
         </p:nvSpPr>
         <p:spPr>
           <a:xfrm>
-            <a:off x="6111240" y="2423160"/>
-            <a:ext cx="2164080" cy="3657600"/>
+            <a:off x="8173516" y="2423160"/>
+            <a:ext cx="3149498" cy="3657600"/>
           </a:xfrm>
           <a:prstGeom prst="rect">
             <a:avLst/>

</xml_diff>